<commit_message>
demo day: a phone teleprompter, and one switch between real money and the testnet
sagepays.xyz/stage/index.html is now the teleprompter for the presenter's second phone, generated
from the same script.js: black, large type, auto-scroll at his speed, the screen kept awake, a clock
that warns at 4:45 and 5:30. SAGE_LIVE=mainnet|testnet rebuilds the deck, the printed script and the
teleprompter with the wording for each network, so the 18:00 decision is one command. Thumbnails
no longer block the build when Keynote is busy.

Co-Authored-By: Claude Opus 5.5 <noreply@anthropic.com>
</commit_message>
<xml_diff>
--- a/docs/fc/demo-day/Sage-DemoDay.pptx
+++ b/docs/fc/demo-day/Sage-DemoDay.pptx
@@ -114,38 +114,38 @@
   <p:extLst>
     <p:ext uri="{521415D9-36F7-43E2-AB2F-B90AF26B5E84}">
       <p14:sectionLst xmlns:p14="http://schemas.microsoft.com/office/powerpoint/2010/main">
-        <p14:section name="Opening" id="{01c5cb19-b6eb-357f-a9df-3b17117a2c51}">
+        <p14:section name="Opening" id="{a43ef30d-9754-9402-f1fd-acf493c1fc9d}">
           <p14:sldIdLst>
             <p14:sldId id="256"/>
           </p14:sldIdLst>
         </p14:section>
-        <p14:section name="Problem" id="{75a02dc2-7673-baf8-7cb3-9c5937eac568}">
+        <p14:section name="Problem" id="{ef6585ab-bbcd-269c-f26b-e2e0faa2342c}">
           <p14:sldIdLst>
             <p14:sldId id="257"/>
           </p14:sldIdLst>
         </p14:section>
-        <p14:section name="Sage" id="{913cd342-e1ca-1f23-a72c-011e7818e230}">
+        <p14:section name="Sage" id="{49c53a44-6f25-2972-57f4-cdac75a520f3}">
           <p14:sldIdLst>
             <p14:sldId id="258"/>
           </p14:sldIdLst>
         </p14:section>
-        <p14:section name="Live" id="{386f22df-f14b-f1f6-17fa-391b8a5597d6}">
+        <p14:section name="Live" id="{be4833a6-ebf1-8faa-7f96-6e483bf43550}">
           <p14:sldIdLst>
             <p14:sldId id="259"/>
           </p14:sldIdLst>
         </p14:section>
-        <p14:section name="Finance" id="{e1e7efa0-0a54-4eef-e542-c3b0cf42b012}">
+        <p14:section name="Finance" id="{2f841590-d193-3122-e19a-540cc189e025}">
           <p14:sldIdLst>
             <p14:sldId id="260"/>
           </p14:sldIdLst>
         </p14:section>
-        <p14:section name="Next" id="{34644bf3-f528-85fd-868d-4ef278da8a64}">
+        <p14:section name="Next" id="{a3cfa9e4-916d-5782-993b-b31e1ccd508a}">
           <p14:sldIdLst>
             <p14:sldId id="261"/>
             <p14:sldId id="262"/>
           </p14:sldIdLst>
         </p14:section>
-        <p14:section name="Close" id="{6d4563b7-76ea-8f05-1966-96584255ff47}">
+        <p14:section name="Close" id="{ae6cd12b-68f2-8ee9-6238-f6ee0ce7e436}">
           <p14:sldIdLst>
             <p14:sldId id="263"/>
           </p14:sldIdLst>
@@ -556,7 +556,7 @@
               <a:rPr lang="en-US" dirty="0"/>
               <a:t>1 · OPENING (to 0:15). Learn these three lines by heart.
 Hi, I'm Shariq, and I built Sage.
-In the next few minutes I'll post a job, and an AI agent will check the work and pay for it. Live. Nobody will approve that payment, not even me.
+In the next few minutes I'll post a job, and an AI agent will check the work and pay for it. Live, with real money. Nobody will approve that payment, not even me.
 But first, why it matters here.</a:t>
             </a:r>
             <a:endParaRPr lang="en-US" dirty="0"/>
@@ -827,7 +827,7 @@
             <a:r>
               <a:rPr lang="en-US" dirty="0"/>
               <a:t>4 · LIVE (to 1:15)
-Let me show you. Live, on Arc's test network, so these are test dollars. The same engine pays real money on mainnet.
+Let me show you. Live, with real money, on Arc, where the dollar pays its own fee.
 &gt;&gt; CMD+TAB TO CHROME: THE BUYER'S WINDOW, ON SAGEPAYS.XYZ, ALREADY SIGNED IN.
 CHROME · BUYER · POST THE JOB (to 1:55)
 I'm the buyer. I write what I want in one sentence, in my own money: put my shop's price list online, three items in Jamaican dollars, J$160.
@@ -836,7 +836,7 @@
 &gt;&gt; WHEN THE FORM FILLS, POINT AT THE RULES AND THE PRICE. TICK "ONLY PEOPLE I INVITE". CLICK "CREATE THE GIG".
 CHROME · BUYER · LAUNCH IT (to 2:15)
 Now I fund it. I don't send money to anyone. Sage creates a vault on chain, funds it from my account, and switches it on.
-&gt;&gt; CLICK "LET SAGE LAUNCH IT FROM YOUR ACCOUNT ON ARC TESTNET".
+&gt;&gt; CLICK "LET SAGE LAUNCH IT FROM YOUR ACCOUNT ON ARC MAINNET".
 Live. The vault holds exactly the reward, and Sage can't pay a cent more.
 &gt;&gt; CLICK "THE BOARD". COPY THE ADDRESS: CMD+L, CMD+C.
 CHROME · SELLER · DO THE WORK (to 2:35)
@@ -1959,7 +1959,7 @@
         <p:spPr>
           <a:xfrm>
             <a:off x="685800" y="4389120"/>
-            <a:ext cx="7863840" cy="713232"/>
+            <a:ext cx="9418320" cy="713232"/>
           </a:xfrm>
           <a:prstGeom prst="roundRect">
             <a:avLst>
@@ -2011,7 +2011,7 @@
         <p:spPr>
           <a:xfrm>
             <a:off x="1371600" y="4389120"/>
-            <a:ext cx="7040880" cy="713232"/>
+            <a:ext cx="8412480" cy="713232"/>
           </a:xfrm>
           <a:prstGeom prst="rect">
             <a:avLst/>
@@ -2035,7 +2035,7 @@
                 <a:ea typeface="Arial" pitchFamily="34" charset="-122"/>
                 <a:cs typeface="Arial" pitchFamily="34" charset="-120"/>
               </a:rPr>
-              <a:t>In the next few minutes, you'll watch it pay someone. Live.</a:t>
+              <a:t>In the next few minutes, you'll watch it pay someone. Live, with real money.</a:t>
             </a:r>
             <a:endParaRPr lang="en-US" sz="2000" dirty="0"/>
           </a:p>
@@ -3584,7 +3584,7 @@
                 <a:ea typeface="Arial" pitchFamily="34" charset="-122"/>
                 <a:cs typeface="Arial" pitchFamily="34" charset="-120"/>
               </a:rPr>
-              <a:t>Read from the public ledger at sagepays.xyz/explorer, 9 Oct 2026</a:t>
+              <a:t>Read from the public ledger at sagepays.xyz/explorer, 10 Oct 2026</a:t>
             </a:r>
             <a:endParaRPr lang="en-US" sz="1100" dirty="0"/>
           </a:p>
@@ -4293,7 +4293,7 @@
                 <a:ea typeface="Arial" pitchFamily="34" charset="-122"/>
                 <a:cs typeface="Arial" pitchFamily="34" charset="-120"/>
               </a:rPr>
-              <a:t>On Arc's test network: test dollars, the real engine. Real money since July: 41 mainnet payments on the public ledger.</a:t>
+              <a:t>Real USDC on Arc mainnet. Every payment is a public transaction. 41 mainnet payments since July.</a:t>
             </a:r>
             <a:endParaRPr lang="en-US" sz="1400" dirty="0"/>
           </a:p>

</xml_diff>

<commit_message>
deck: slide 5 says the receipt is from a real-money rehearsal on Arc mainnet
Co-Authored-By: Claude Opus 5.5 <noreply@anthropic.com>
</commit_message>
<xml_diff>
--- a/docs/fc/demo-day/Sage-DemoDay.pptx
+++ b/docs/fc/demo-day/Sage-DemoDay.pptx
@@ -114,38 +114,38 @@
   <p:extLst>
     <p:ext uri="{521415D9-36F7-43E2-AB2F-B90AF26B5E84}">
       <p14:sectionLst xmlns:p14="http://schemas.microsoft.com/office/powerpoint/2010/main">
-        <p14:section name="Opening" id="{6c463ca9-4103-c671-654c-39612a0ccf85}">
+        <p14:section name="Opening" id="{ae565b24-7cf7-0120-b693-aed180c791e5}">
           <p14:sldIdLst>
             <p14:sldId id="256"/>
           </p14:sldIdLst>
         </p14:section>
-        <p14:section name="Problem" id="{4d4589ea-73e1-4805-6e18-8f42ffbc5e65}">
+        <p14:section name="Problem" id="{c637d14a-8296-0729-6a05-6497ae891e26}">
           <p14:sldIdLst>
             <p14:sldId id="257"/>
           </p14:sldIdLst>
         </p14:section>
-        <p14:section name="Sage" id="{3ce3d858-7475-a6c8-e623-36c8536a91be}">
+        <p14:section name="Sage" id="{1d8d99f1-4be4-3b68-162c-a54897e8fd96}">
           <p14:sldIdLst>
             <p14:sldId id="258"/>
           </p14:sldIdLst>
         </p14:section>
-        <p14:section name="Live" id="{134f0a95-608f-5fa4-3cff-3ad42bd1df8f}">
+        <p14:section name="Live" id="{07733bff-dc58-0fd2-6c04-5502ab1b938f}">
           <p14:sldIdLst>
             <p14:sldId id="259"/>
           </p14:sldIdLst>
         </p14:section>
-        <p14:section name="Finance" id="{61eb47f5-fe33-93ed-dd16-55feaeec417a}">
+        <p14:section name="Finance" id="{b6b55d1f-af14-c282-5819-72615853658a}">
           <p14:sldIdLst>
             <p14:sldId id="260"/>
           </p14:sldIdLst>
         </p14:section>
-        <p14:section name="Next" id="{69e0f1e1-fcc7-d18b-1a31-843ed6003a30}">
+        <p14:section name="Next" id="{87c2800b-68f8-36f0-f2fa-7f36f22db2c4}">
           <p14:sldIdLst>
             <p14:sldId id="261"/>
             <p14:sldId id="262"/>
           </p14:sldIdLst>
         </p14:section>
-        <p14:section name="Close" id="{929d4c3a-bad7-27a3-e8bf-8d04f372a12e}">
+        <p14:section name="Close" id="{13b9d080-29eb-c7c1-5491-482d1ae8fd3d}">
           <p14:sldIdLst>
             <p14:sldId id="263"/>
           </p14:sldIdLst>
@@ -3274,7 +3274,7 @@
                 <a:ea typeface="Arial" pitchFamily="34" charset="-122"/>
                 <a:cs typeface="Arial" pitchFamily="34" charset="-120"/>
               </a:rPr>
-              <a:t>$76.23</a:t>
+              <a:t>$76.48</a:t>
             </a:r>
             <a:endParaRPr lang="en-US" sz="2600" dirty="0"/>
           </a:p>
@@ -3352,7 +3352,7 @@
                 <a:ea typeface="Arial" pitchFamily="34" charset="-122"/>
                 <a:cs typeface="Arial" pitchFamily="34" charset="-120"/>
               </a:rPr>
-              <a:t>44</a:t>
+              <a:t>45</a:t>
             </a:r>
             <a:endParaRPr lang="en-US" sz="2600" dirty="0"/>
           </a:p>
@@ -4295,7 +4295,7 @@
                 <a:ea typeface="Arial" pitchFamily="34" charset="-122"/>
                 <a:cs typeface="Arial" pitchFamily="34" charset="-120"/>
               </a:rPr>
-              <a:t>Real USDC on Arc mainnet. Every payment is a public transaction. 44 mainnet payments since July.</a:t>
+              <a:t>Real USDC on Arc mainnet. Every payment is a public transaction. 45 mainnet payments since July.</a:t>
             </a:r>
             <a:endParaRPr lang="en-US" sz="1400" dirty="0"/>
           </a:p>
@@ -4455,7 +4455,7 @@
                 <a:ea typeface="Arial" pitchFamily="34" charset="-122"/>
                 <a:cs typeface="Arial" pitchFamily="34" charset="-120"/>
               </a:rPr>
-              <a:t>The decision Sage recorded on a rehearsal run</a:t>
+              <a:t>The decision Sage recorded on a real-money rehearsal (Arc mainnet)</a:t>
             </a:r>
             <a:endParaRPr lang="en-US" sz="1100" dirty="0"/>
           </a:p>

</xml_diff>